<commit_message>
Replace benefits bullets with visual 3x2 card grid
Slide 7 now shows six benefit cards on a dark background, each with:
- Colored accent stripe and badge (DAYS->MIN, DAY 1, 0 ERRORS, etc.)
- Bold title + description paragraph
- Bottom metric tag (10x faster, Zero ramp-up, First in market, etc.)

Benefits and Next Steps split into two slides (7 and 8) bringing
the executive deck to 8 slides total.

Co-Authored-By: Claude Opus 4.6 <noreply@anthropic.com>
</commit_message>
<xml_diff>
--- a/docs/Agentic_Health_Interop_Executive.pptx
+++ b/docs/Agentic_Health_Interop_Executive.pptx
@@ -12,6 +12,7 @@
     <p:sldId id="260" r:id="rId11"/>
     <p:sldId id="261" r:id="rId12"/>
     <p:sldId id="262" r:id="rId13"/>
+    <p:sldId id="263" r:id="rId14"/>
   </p:sldIdLst>
   <p:sldSz cx="12191695" cy="6858000" type="screen4x3"/>
   <p:notesSz cx="6858000" cy="9144000"/>
@@ -6685,7 +6686,7 @@
           <a:lstStyle/>
           <a:p>
             <a:pPr algn="l">
-              <a:defRPr sz="3000" b="1">
+              <a:defRPr sz="3200" b="1">
                 <a:solidFill>
                   <a:srgbClr val="E6E8EB"/>
                 </a:solidFill>
@@ -6693,7 +6694,7 @@
               </a:defRPr>
             </a:pPr>
             <a:r>
-              <a:t>Benefits &amp; Next Steps</a:t>
+              <a:t>Why This Matters</a:t>
             </a:r>
           </a:p>
         </p:txBody>
@@ -6743,14 +6744,157 @@
       </p:sp>
       <p:sp>
         <p:nvSpPr>
-          <p:cNvPr id="4" name="TextBox 3"/>
+          <p:cNvPr id="4" name="Rounded Rectangle 3"/>
+          <p:cNvSpPr/>
+          <p:nvPr/>
+        </p:nvSpPr>
+        <p:spPr>
+          <a:xfrm>
+            <a:off x="731520" y="1280160"/>
+            <a:ext cx="3383280" cy="2331720"/>
+          </a:xfrm>
+          <a:prstGeom prst="roundRect">
+            <a:avLst/>
+          </a:prstGeom>
+          <a:solidFill>
+            <a:srgbClr val="13171E"/>
+          </a:solidFill>
+          <a:ln>
+            <a:noFill/>
+          </a:ln>
+        </p:spPr>
+        <p:style>
+          <a:lnRef idx="1">
+            <a:schemeClr val="accent1"/>
+          </a:lnRef>
+          <a:fillRef idx="3">
+            <a:schemeClr val="accent1"/>
+          </a:fillRef>
+          <a:effectRef idx="2">
+            <a:schemeClr val="accent1"/>
+          </a:effectRef>
+          <a:fontRef idx="minor">
+            <a:schemeClr val="lt1"/>
+          </a:fontRef>
+        </p:style>
+        <p:txBody>
+          <a:bodyPr rtlCol="0" anchor="ctr"/>
+          <a:lstStyle/>
+          <a:p>
+            <a:pPr algn="ctr"/>
+          </a:p>
+        </p:txBody>
+      </p:sp>
+      <p:sp>
+        <p:nvSpPr>
+          <p:cNvPr id="5" name="Rectangle 4"/>
+          <p:cNvSpPr/>
+          <p:nvPr/>
+        </p:nvSpPr>
+        <p:spPr>
+          <a:xfrm>
+            <a:off x="731520" y="1280160"/>
+            <a:ext cx="63500" cy="2331720"/>
+          </a:xfrm>
+          <a:prstGeom prst="rect">
+            <a:avLst/>
+          </a:prstGeom>
+          <a:solidFill>
+            <a:srgbClr val="14B8A6"/>
+          </a:solidFill>
+          <a:ln>
+            <a:noFill/>
+          </a:ln>
+        </p:spPr>
+        <p:style>
+          <a:lnRef idx="1">
+            <a:schemeClr val="accent1"/>
+          </a:lnRef>
+          <a:fillRef idx="3">
+            <a:schemeClr val="accent1"/>
+          </a:fillRef>
+          <a:effectRef idx="2">
+            <a:schemeClr val="accent1"/>
+          </a:effectRef>
+          <a:fontRef idx="minor">
+            <a:schemeClr val="lt1"/>
+          </a:fontRef>
+        </p:style>
+        <p:txBody>
+          <a:bodyPr rtlCol="0" anchor="ctr"/>
+          <a:lstStyle/>
+          <a:p>
+            <a:pPr algn="ctr"/>
+          </a:p>
+        </p:txBody>
+      </p:sp>
+      <p:sp>
+        <p:nvSpPr>
+          <p:cNvPr id="6" name="Rounded Rectangle 5"/>
+          <p:cNvSpPr/>
+          <p:nvPr/>
+        </p:nvSpPr>
+        <p:spPr>
+          <a:xfrm>
+            <a:off x="3154680" y="1417320"/>
+            <a:ext cx="822960" cy="502920"/>
+          </a:xfrm>
+          <a:prstGeom prst="roundRect">
+            <a:avLst/>
+          </a:prstGeom>
+          <a:solidFill>
+            <a:srgbClr val="14B8A6"/>
+          </a:solidFill>
+          <a:ln>
+            <a:noFill/>
+          </a:ln>
+        </p:spPr>
+        <p:style>
+          <a:lnRef idx="1">
+            <a:schemeClr val="accent1"/>
+          </a:lnRef>
+          <a:fillRef idx="3">
+            <a:schemeClr val="accent1"/>
+          </a:fillRef>
+          <a:effectRef idx="2">
+            <a:schemeClr val="accent1"/>
+          </a:effectRef>
+          <a:fontRef idx="minor">
+            <a:schemeClr val="lt1"/>
+          </a:fontRef>
+        </p:style>
+        <p:txBody>
+          <a:bodyPr rtlCol="0" anchor="ctr" wrap="square" lIns="76200" rIns="76200" tIns="50800" bIns="50800"/>
+          <a:lstStyle/>
+          <a:p>
+            <a:pPr algn="ctr">
+              <a:defRPr sz="900" b="1">
+                <a:solidFill>
+                  <a:srgbClr val="E6E8EB"/>
+                </a:solidFill>
+                <a:latin typeface="Calibri"/>
+              </a:defRPr>
+            </a:pPr>
+            <a:r>
+              <a:t>DAYS</a:t>
+            </a:r>
+            <a:br/>
+            <a:r>
+              <a:t>  MIN</a:t>
+            </a:r>
+          </a:p>
+        </p:txBody>
+      </p:sp>
+      <p:sp>
+        <p:nvSpPr>
+          <p:cNvPr id="7" name="TextBox 6"/>
           <p:cNvSpPr txBox="1"/>
           <p:nvPr/>
         </p:nvSpPr>
         <p:spPr>
           <a:xfrm>
-            <a:off x="731520" y="1371600"/>
-            <a:ext cx="5029200" cy="4572000"/>
+            <a:off x="960120" y="1417320"/>
+            <a:ext cx="2103120" cy="365760"/>
           </a:xfrm>
           <a:prstGeom prst="rect">
             <a:avLst/>
@@ -6764,31 +6908,1797 @@
           <a:lstStyle/>
           <a:p>
             <a:pPr algn="l">
-              <a:defRPr sz="2000" b="1">
-                <a:solidFill>
-                  <a:srgbClr val="606FF3"/>
-                </a:solidFill>
-                <a:latin typeface="Calibri"/>
-              </a:defRPr>
-            </a:pPr>
-            <a:r>
-              <a:t>Benefits</a:t>
-            </a:r>
+              <a:defRPr sz="1600" b="1">
+                <a:solidFill>
+                  <a:srgbClr val="E6E8EB"/>
+                </a:solidFill>
+                <a:latin typeface="Calibri"/>
+              </a:defRPr>
+            </a:pPr>
+            <a:r>
+              <a:t>Faster Time-to-Value</a:t>
+            </a:r>
+          </a:p>
+        </p:txBody>
+      </p:sp>
+      <p:sp>
+        <p:nvSpPr>
+          <p:cNvPr id="8" name="TextBox 7"/>
+          <p:cNvSpPr txBox="1"/>
+          <p:nvPr/>
+        </p:nvSpPr>
+        <p:spPr>
+          <a:xfrm>
+            <a:off x="960120" y="1828800"/>
+            <a:ext cx="2926080" cy="1188720"/>
+          </a:xfrm>
+          <a:prstGeom prst="rect">
+            <a:avLst/>
+          </a:prstGeom>
+          <a:noFill/>
+        </p:spPr>
+        <p:txBody>
+          <a:bodyPr wrap="square">
+            <a:spAutoFit/>
+          </a:bodyPr>
+          <a:lstStyle/>
+          <a:p>
+            <a:pPr algn="l">
+              <a:defRPr sz="1100" b="0">
+                <a:solidFill>
+                  <a:srgbClr val="8B95A5"/>
+                </a:solidFill>
+                <a:latin typeface="Calibri"/>
+              </a:defRPr>
+            </a:pPr>
+            <a:r>
+              <a:t>Engineers describe what they need in plain English. The agent builds, configures, and validates -- reducing production setup from days to minutes.</a:t>
+            </a:r>
+          </a:p>
+        </p:txBody>
+      </p:sp>
+      <p:sp>
+        <p:nvSpPr>
+          <p:cNvPr id="9" name="Rounded Rectangle 8"/>
+          <p:cNvSpPr/>
+          <p:nvPr/>
+        </p:nvSpPr>
+        <p:spPr>
+          <a:xfrm>
+            <a:off x="960120" y="3154680"/>
+            <a:ext cx="1371600" cy="274320"/>
+          </a:xfrm>
+          <a:prstGeom prst="roundRect">
+            <a:avLst/>
+          </a:prstGeom>
+          <a:solidFill>
+            <a:srgbClr val="14B8A6"/>
+          </a:solidFill>
+          <a:ln>
+            <a:noFill/>
+          </a:ln>
+        </p:spPr>
+        <p:style>
+          <a:lnRef idx="1">
+            <a:schemeClr val="accent1"/>
+          </a:lnRef>
+          <a:fillRef idx="3">
+            <a:schemeClr val="accent1"/>
+          </a:fillRef>
+          <a:effectRef idx="2">
+            <a:schemeClr val="accent1"/>
+          </a:effectRef>
+          <a:fontRef idx="minor">
+            <a:schemeClr val="lt1"/>
+          </a:fontRef>
+        </p:style>
+        <p:txBody>
+          <a:bodyPr rtlCol="0" anchor="ctr" wrap="square" lIns="76200" rIns="76200" tIns="50800" bIns="50800"/>
+          <a:lstStyle/>
+          <a:p>
+            <a:pPr algn="ctr">
+              <a:defRPr sz="1000" b="1">
+                <a:solidFill>
+                  <a:srgbClr val="E6E8EB"/>
+                </a:solidFill>
+                <a:latin typeface="Calibri"/>
+              </a:defRPr>
+            </a:pPr>
+            <a:r>
+              <a:t>10x faster</a:t>
+            </a:r>
+          </a:p>
+        </p:txBody>
+      </p:sp>
+      <p:sp>
+        <p:nvSpPr>
+          <p:cNvPr id="10" name="Rounded Rectangle 9"/>
+          <p:cNvSpPr/>
+          <p:nvPr/>
+        </p:nvSpPr>
+        <p:spPr>
+          <a:xfrm>
+            <a:off x="4434840" y="1280160"/>
+            <a:ext cx="3383280" cy="2331720"/>
+          </a:xfrm>
+          <a:prstGeom prst="roundRect">
+            <a:avLst/>
+          </a:prstGeom>
+          <a:solidFill>
+            <a:srgbClr val="13171E"/>
+          </a:solidFill>
+          <a:ln>
+            <a:noFill/>
+          </a:ln>
+        </p:spPr>
+        <p:style>
+          <a:lnRef idx="1">
+            <a:schemeClr val="accent1"/>
+          </a:lnRef>
+          <a:fillRef idx="3">
+            <a:schemeClr val="accent1"/>
+          </a:fillRef>
+          <a:effectRef idx="2">
+            <a:schemeClr val="accent1"/>
+          </a:effectRef>
+          <a:fontRef idx="minor">
+            <a:schemeClr val="lt1"/>
+          </a:fontRef>
+        </p:style>
+        <p:txBody>
+          <a:bodyPr rtlCol="0" anchor="ctr"/>
+          <a:lstStyle/>
+          <a:p>
+            <a:pPr algn="ctr"/>
+          </a:p>
+        </p:txBody>
+      </p:sp>
+      <p:sp>
+        <p:nvSpPr>
+          <p:cNvPr id="11" name="Rectangle 10"/>
+          <p:cNvSpPr/>
+          <p:nvPr/>
+        </p:nvSpPr>
+        <p:spPr>
+          <a:xfrm>
+            <a:off x="4434840" y="1280160"/>
+            <a:ext cx="63500" cy="2331720"/>
+          </a:xfrm>
+          <a:prstGeom prst="rect">
+            <a:avLst/>
+          </a:prstGeom>
+          <a:solidFill>
+            <a:srgbClr val="22C55E"/>
+          </a:solidFill>
+          <a:ln>
+            <a:noFill/>
+          </a:ln>
+        </p:spPr>
+        <p:style>
+          <a:lnRef idx="1">
+            <a:schemeClr val="accent1"/>
+          </a:lnRef>
+          <a:fillRef idx="3">
+            <a:schemeClr val="accent1"/>
+          </a:fillRef>
+          <a:effectRef idx="2">
+            <a:schemeClr val="accent1"/>
+          </a:effectRef>
+          <a:fontRef idx="minor">
+            <a:schemeClr val="lt1"/>
+          </a:fontRef>
+        </p:style>
+        <p:txBody>
+          <a:bodyPr rtlCol="0" anchor="ctr"/>
+          <a:lstStyle/>
+          <a:p>
+            <a:pPr algn="ctr"/>
+          </a:p>
+        </p:txBody>
+      </p:sp>
+      <p:sp>
+        <p:nvSpPr>
+          <p:cNvPr id="12" name="Rounded Rectangle 11"/>
+          <p:cNvSpPr/>
+          <p:nvPr/>
+        </p:nvSpPr>
+        <p:spPr>
+          <a:xfrm>
+            <a:off x="6858000" y="1417320"/>
+            <a:ext cx="822960" cy="502920"/>
+          </a:xfrm>
+          <a:prstGeom prst="roundRect">
+            <a:avLst/>
+          </a:prstGeom>
+          <a:solidFill>
+            <a:srgbClr val="22C55E"/>
+          </a:solidFill>
+          <a:ln>
+            <a:noFill/>
+          </a:ln>
+        </p:spPr>
+        <p:style>
+          <a:lnRef idx="1">
+            <a:schemeClr val="accent1"/>
+          </a:lnRef>
+          <a:fillRef idx="3">
+            <a:schemeClr val="accent1"/>
+          </a:fillRef>
+          <a:effectRef idx="2">
+            <a:schemeClr val="accent1"/>
+          </a:effectRef>
+          <a:fontRef idx="minor">
+            <a:schemeClr val="lt1"/>
+          </a:fontRef>
+        </p:style>
+        <p:txBody>
+          <a:bodyPr rtlCol="0" anchor="ctr" wrap="square" lIns="76200" rIns="76200" tIns="50800" bIns="50800"/>
+          <a:lstStyle/>
+          <a:p>
+            <a:pPr algn="ctr">
+              <a:defRPr sz="900" b="1">
+                <a:solidFill>
+                  <a:srgbClr val="E6E8EB"/>
+                </a:solidFill>
+                <a:latin typeface="Calibri"/>
+              </a:defRPr>
+            </a:pPr>
+            <a:r>
+              <a:t>DAY 1</a:t>
+            </a:r>
+          </a:p>
+        </p:txBody>
+      </p:sp>
+      <p:sp>
+        <p:nvSpPr>
+          <p:cNvPr id="13" name="TextBox 12"/>
+          <p:cNvSpPr txBox="1"/>
+          <p:nvPr/>
+        </p:nvSpPr>
+        <p:spPr>
+          <a:xfrm>
+            <a:off x="4663440" y="1417320"/>
+            <a:ext cx="2103120" cy="365760"/>
+          </a:xfrm>
+          <a:prstGeom prst="rect">
+            <a:avLst/>
+          </a:prstGeom>
+          <a:noFill/>
+        </p:spPr>
+        <p:txBody>
+          <a:bodyPr wrap="square">
+            <a:spAutoFit/>
+          </a:bodyPr>
+          <a:lstStyle/>
+          <a:p>
+            <a:pPr algn="l">
+              <a:defRPr sz="1600" b="1">
+                <a:solidFill>
+                  <a:srgbClr val="E6E8EB"/>
+                </a:solidFill>
+                <a:latin typeface="Calibri"/>
+              </a:defRPr>
+            </a:pPr>
+            <a:r>
+              <a:t>Lower Barrier to Entry</a:t>
+            </a:r>
+          </a:p>
+        </p:txBody>
+      </p:sp>
+      <p:sp>
+        <p:nvSpPr>
+          <p:cNvPr id="14" name="TextBox 13"/>
+          <p:cNvSpPr txBox="1"/>
+          <p:nvPr/>
+        </p:nvSpPr>
+        <p:spPr>
+          <a:xfrm>
+            <a:off x="4663440" y="1828800"/>
+            <a:ext cx="2926080" cy="1188720"/>
+          </a:xfrm>
+          <a:prstGeom prst="rect">
+            <a:avLst/>
+          </a:prstGeom>
+          <a:noFill/>
+        </p:spPr>
+        <p:txBody>
+          <a:bodyPr wrap="square">
+            <a:spAutoFit/>
+          </a:bodyPr>
+          <a:lstStyle/>
+          <a:p>
+            <a:pPr algn="l">
+              <a:defRPr sz="1100" b="0">
+                <a:solidFill>
+                  <a:srgbClr val="8B95A5"/>
+                </a:solidFill>
+                <a:latin typeface="Calibri"/>
+              </a:defRPr>
+            </a:pPr>
+            <a:r>
+              <a:t>New engineers are productive immediately. Natural-language guidance replaces the steep learning curve of ObjectScript, DTL, and the Ens.* class library.</a:t>
+            </a:r>
+          </a:p>
+        </p:txBody>
+      </p:sp>
+      <p:sp>
+        <p:nvSpPr>
+          <p:cNvPr id="15" name="Rounded Rectangle 14"/>
+          <p:cNvSpPr/>
+          <p:nvPr/>
+        </p:nvSpPr>
+        <p:spPr>
+          <a:xfrm>
+            <a:off x="4663440" y="3154680"/>
+            <a:ext cx="1371600" cy="274320"/>
+          </a:xfrm>
+          <a:prstGeom prst="roundRect">
+            <a:avLst/>
+          </a:prstGeom>
+          <a:solidFill>
+            <a:srgbClr val="22C55E"/>
+          </a:solidFill>
+          <a:ln>
+            <a:noFill/>
+          </a:ln>
+        </p:spPr>
+        <p:style>
+          <a:lnRef idx="1">
+            <a:schemeClr val="accent1"/>
+          </a:lnRef>
+          <a:fillRef idx="3">
+            <a:schemeClr val="accent1"/>
+          </a:fillRef>
+          <a:effectRef idx="2">
+            <a:schemeClr val="accent1"/>
+          </a:effectRef>
+          <a:fontRef idx="minor">
+            <a:schemeClr val="lt1"/>
+          </a:fontRef>
+        </p:style>
+        <p:txBody>
+          <a:bodyPr rtlCol="0" anchor="ctr" wrap="square" lIns="76200" rIns="76200" tIns="50800" bIns="50800"/>
+          <a:lstStyle/>
+          <a:p>
+            <a:pPr algn="ctr">
+              <a:defRPr sz="1000" b="1">
+                <a:solidFill>
+                  <a:srgbClr val="E6E8EB"/>
+                </a:solidFill>
+                <a:latin typeface="Calibri"/>
+              </a:defRPr>
+            </a:pPr>
+            <a:r>
+              <a:t>Zero ramp-up</a:t>
+            </a:r>
+          </a:p>
+        </p:txBody>
+      </p:sp>
+      <p:sp>
+        <p:nvSpPr>
+          <p:cNvPr id="16" name="Rounded Rectangle 15"/>
+          <p:cNvSpPr/>
+          <p:nvPr/>
+        </p:nvSpPr>
+        <p:spPr>
+          <a:xfrm>
+            <a:off x="8138160" y="1280160"/>
+            <a:ext cx="3383280" cy="2331720"/>
+          </a:xfrm>
+          <a:prstGeom prst="roundRect">
+            <a:avLst/>
+          </a:prstGeom>
+          <a:solidFill>
+            <a:srgbClr val="13171E"/>
+          </a:solidFill>
+          <a:ln>
+            <a:noFill/>
+          </a:ln>
+        </p:spPr>
+        <p:style>
+          <a:lnRef idx="1">
+            <a:schemeClr val="accent1"/>
+          </a:lnRef>
+          <a:fillRef idx="3">
+            <a:schemeClr val="accent1"/>
+          </a:fillRef>
+          <a:effectRef idx="2">
+            <a:schemeClr val="accent1"/>
+          </a:effectRef>
+          <a:fontRef idx="minor">
+            <a:schemeClr val="lt1"/>
+          </a:fontRef>
+        </p:style>
+        <p:txBody>
+          <a:bodyPr rtlCol="0" anchor="ctr"/>
+          <a:lstStyle/>
+          <a:p>
+            <a:pPr algn="ctr"/>
+          </a:p>
+        </p:txBody>
+      </p:sp>
+      <p:sp>
+        <p:nvSpPr>
+          <p:cNvPr id="17" name="Rectangle 16"/>
+          <p:cNvSpPr/>
+          <p:nvPr/>
+        </p:nvSpPr>
+        <p:spPr>
+          <a:xfrm>
+            <a:off x="8138160" y="1280160"/>
+            <a:ext cx="63500" cy="2331720"/>
+          </a:xfrm>
+          <a:prstGeom prst="rect">
+            <a:avLst/>
+          </a:prstGeom>
+          <a:solidFill>
+            <a:srgbClr val="606FF3"/>
+          </a:solidFill>
+          <a:ln>
+            <a:noFill/>
+          </a:ln>
+        </p:spPr>
+        <p:style>
+          <a:lnRef idx="1">
+            <a:schemeClr val="accent1"/>
+          </a:lnRef>
+          <a:fillRef idx="3">
+            <a:schemeClr val="accent1"/>
+          </a:fillRef>
+          <a:effectRef idx="2">
+            <a:schemeClr val="accent1"/>
+          </a:effectRef>
+          <a:fontRef idx="minor">
+            <a:schemeClr val="lt1"/>
+          </a:fontRef>
+        </p:style>
+        <p:txBody>
+          <a:bodyPr rtlCol="0" anchor="ctr"/>
+          <a:lstStyle/>
+          <a:p>
+            <a:pPr algn="ctr"/>
+          </a:p>
+        </p:txBody>
+      </p:sp>
+      <p:sp>
+        <p:nvSpPr>
+          <p:cNvPr id="18" name="Rounded Rectangle 17"/>
+          <p:cNvSpPr/>
+          <p:nvPr/>
+        </p:nvSpPr>
+        <p:spPr>
+          <a:xfrm>
+            <a:off x="10561320" y="1417320"/>
+            <a:ext cx="822960" cy="502920"/>
+          </a:xfrm>
+          <a:prstGeom prst="roundRect">
+            <a:avLst/>
+          </a:prstGeom>
+          <a:solidFill>
+            <a:srgbClr val="606FF3"/>
+          </a:solidFill>
+          <a:ln>
+            <a:noFill/>
+          </a:ln>
+        </p:spPr>
+        <p:style>
+          <a:lnRef idx="1">
+            <a:schemeClr val="accent1"/>
+          </a:lnRef>
+          <a:fillRef idx="3">
+            <a:schemeClr val="accent1"/>
+          </a:fillRef>
+          <a:effectRef idx="2">
+            <a:schemeClr val="accent1"/>
+          </a:effectRef>
+          <a:fontRef idx="minor">
+            <a:schemeClr val="lt1"/>
+          </a:fontRef>
+        </p:style>
+        <p:txBody>
+          <a:bodyPr rtlCol="0" anchor="ctr" wrap="square" lIns="76200" rIns="76200" tIns="50800" bIns="50800"/>
+          <a:lstStyle/>
+          <a:p>
+            <a:pPr algn="ctr">
+              <a:defRPr sz="900" b="1">
+                <a:solidFill>
+                  <a:srgbClr val="E6E8EB"/>
+                </a:solidFill>
+                <a:latin typeface="Calibri"/>
+              </a:defRPr>
+            </a:pPr>
+            <a:r>
+              <a:t>0</a:t>
+            </a:r>
+            <a:br/>
+            <a:r>
+              <a:t>ERRORS</a:t>
+            </a:r>
+          </a:p>
+        </p:txBody>
+      </p:sp>
+      <p:sp>
+        <p:nvSpPr>
+          <p:cNvPr id="19" name="TextBox 18"/>
+          <p:cNvSpPr txBox="1"/>
+          <p:nvPr/>
+        </p:nvSpPr>
+        <p:spPr>
+          <a:xfrm>
+            <a:off x="8366760" y="1417320"/>
+            <a:ext cx="2103120" cy="365760"/>
+          </a:xfrm>
+          <a:prstGeom prst="rect">
+            <a:avLst/>
+          </a:prstGeom>
+          <a:noFill/>
+        </p:spPr>
+        <p:txBody>
+          <a:bodyPr wrap="square">
+            <a:spAutoFit/>
+          </a:bodyPr>
+          <a:lstStyle/>
+          <a:p>
+            <a:pPr algn="l">
+              <a:defRPr sz="1600" b="1">
+                <a:solidFill>
+                  <a:srgbClr val="E6E8EB"/>
+                </a:solidFill>
+                <a:latin typeface="Calibri"/>
+              </a:defRPr>
+            </a:pPr>
+            <a:r>
+              <a:t>Higher Quality</a:t>
+            </a:r>
+          </a:p>
+        </p:txBody>
+      </p:sp>
+      <p:sp>
+        <p:nvSpPr>
+          <p:cNvPr id="20" name="TextBox 19"/>
+          <p:cNvSpPr txBox="1"/>
+          <p:nvPr/>
+        </p:nvSpPr>
+        <p:spPr>
+          <a:xfrm>
+            <a:off x="8366760" y="1828800"/>
+            <a:ext cx="2926080" cy="1188720"/>
+          </a:xfrm>
+          <a:prstGeom prst="rect">
+            <a:avLst/>
+          </a:prstGeom>
+          <a:noFill/>
+        </p:spPr>
+        <p:txBody>
+          <a:bodyPr wrap="square">
+            <a:spAutoFit/>
+          </a:bodyPr>
+          <a:lstStyle/>
+          <a:p>
+            <a:pPr algn="l">
+              <a:defRPr sz="1100" b="0">
+                <a:solidFill>
+                  <a:srgbClr val="8B95A5"/>
+                </a:solidFill>
+                <a:latin typeface="Calibri"/>
+              </a:defRPr>
+            </a:pPr>
+            <a:r>
+              <a:t>Automated PostBuildValidation catches misconfigurations, missing settings, and broken routing before they ever reach a live production environment.</a:t>
+            </a:r>
+          </a:p>
+        </p:txBody>
+      </p:sp>
+      <p:sp>
+        <p:nvSpPr>
+          <p:cNvPr id="21" name="Rounded Rectangle 20"/>
+          <p:cNvSpPr/>
+          <p:nvPr/>
+        </p:nvSpPr>
+        <p:spPr>
+          <a:xfrm>
+            <a:off x="8366760" y="3154680"/>
+            <a:ext cx="1371600" cy="274320"/>
+          </a:xfrm>
+          <a:prstGeom prst="roundRect">
+            <a:avLst/>
+          </a:prstGeom>
+          <a:solidFill>
+            <a:srgbClr val="606FF3"/>
+          </a:solidFill>
+          <a:ln>
+            <a:noFill/>
+          </a:ln>
+        </p:spPr>
+        <p:style>
+          <a:lnRef idx="1">
+            <a:schemeClr val="accent1"/>
+          </a:lnRef>
+          <a:fillRef idx="3">
+            <a:schemeClr val="accent1"/>
+          </a:fillRef>
+          <a:effectRef idx="2">
+            <a:schemeClr val="accent1"/>
+          </a:effectRef>
+          <a:fontRef idx="minor">
+            <a:schemeClr val="lt1"/>
+          </a:fontRef>
+        </p:style>
+        <p:txBody>
+          <a:bodyPr rtlCol="0" anchor="ctr" wrap="square" lIns="76200" rIns="76200" tIns="50800" bIns="50800"/>
+          <a:lstStyle/>
+          <a:p>
+            <a:pPr algn="ctr">
+              <a:defRPr sz="1000" b="1">
+                <a:solidFill>
+                  <a:srgbClr val="E6E8EB"/>
+                </a:solidFill>
+                <a:latin typeface="Calibri"/>
+              </a:defRPr>
+            </a:pPr>
+            <a:r>
+              <a:t>Built-in validation</a:t>
+            </a:r>
+          </a:p>
+        </p:txBody>
+      </p:sp>
+      <p:sp>
+        <p:nvSpPr>
+          <p:cNvPr id="22" name="Rounded Rectangle 21"/>
+          <p:cNvSpPr/>
+          <p:nvPr/>
+        </p:nvSpPr>
+        <p:spPr>
+          <a:xfrm>
+            <a:off x="731520" y="3931920"/>
+            <a:ext cx="3383280" cy="2331720"/>
+          </a:xfrm>
+          <a:prstGeom prst="roundRect">
+            <a:avLst/>
+          </a:prstGeom>
+          <a:solidFill>
+            <a:srgbClr val="13171E"/>
+          </a:solidFill>
+          <a:ln>
+            <a:noFill/>
+          </a:ln>
+        </p:spPr>
+        <p:style>
+          <a:lnRef idx="1">
+            <a:schemeClr val="accent1"/>
+          </a:lnRef>
+          <a:fillRef idx="3">
+            <a:schemeClr val="accent1"/>
+          </a:fillRef>
+          <a:effectRef idx="2">
+            <a:schemeClr val="accent1"/>
+          </a:effectRef>
+          <a:fontRef idx="minor">
+            <a:schemeClr val="lt1"/>
+          </a:fontRef>
+        </p:style>
+        <p:txBody>
+          <a:bodyPr rtlCol="0" anchor="ctr"/>
+          <a:lstStyle/>
+          <a:p>
+            <a:pPr algn="ctr"/>
+          </a:p>
+        </p:txBody>
+      </p:sp>
+      <p:sp>
+        <p:nvSpPr>
+          <p:cNvPr id="23" name="Rectangle 22"/>
+          <p:cNvSpPr/>
+          <p:nvPr/>
+        </p:nvSpPr>
+        <p:spPr>
+          <a:xfrm>
+            <a:off x="731520" y="3931920"/>
+            <a:ext cx="63500" cy="2331720"/>
+          </a:xfrm>
+          <a:prstGeom prst="rect">
+            <a:avLst/>
+          </a:prstGeom>
+          <a:solidFill>
+            <a:srgbClr val="007BC0"/>
+          </a:solidFill>
+          <a:ln>
+            <a:noFill/>
+          </a:ln>
+        </p:spPr>
+        <p:style>
+          <a:lnRef idx="1">
+            <a:schemeClr val="accent1"/>
+          </a:lnRef>
+          <a:fillRef idx="3">
+            <a:schemeClr val="accent1"/>
+          </a:fillRef>
+          <a:effectRef idx="2">
+            <a:schemeClr val="accent1"/>
+          </a:effectRef>
+          <a:fontRef idx="minor">
+            <a:schemeClr val="lt1"/>
+          </a:fontRef>
+        </p:style>
+        <p:txBody>
+          <a:bodyPr rtlCol="0" anchor="ctr"/>
+          <a:lstStyle/>
+          <a:p>
+            <a:pPr algn="ctr"/>
+          </a:p>
+        </p:txBody>
+      </p:sp>
+      <p:sp>
+        <p:nvSpPr>
+          <p:cNvPr id="24" name="Rounded Rectangle 23"/>
+          <p:cNvSpPr/>
+          <p:nvPr/>
+        </p:nvSpPr>
+        <p:spPr>
+          <a:xfrm>
+            <a:off x="3154680" y="4069080"/>
+            <a:ext cx="822960" cy="502920"/>
+          </a:xfrm>
+          <a:prstGeom prst="roundRect">
+            <a:avLst/>
+          </a:prstGeom>
+          <a:solidFill>
+            <a:srgbClr val="007BC0"/>
+          </a:solidFill>
+          <a:ln>
+            <a:noFill/>
+          </a:ln>
+        </p:spPr>
+        <p:style>
+          <a:lnRef idx="1">
+            <a:schemeClr val="accent1"/>
+          </a:lnRef>
+          <a:fillRef idx="3">
+            <a:schemeClr val="accent1"/>
+          </a:fillRef>
+          <a:effectRef idx="2">
+            <a:schemeClr val="accent1"/>
+          </a:effectRef>
+          <a:fontRef idx="minor">
+            <a:schemeClr val="lt1"/>
+          </a:fontRef>
+        </p:style>
+        <p:txBody>
+          <a:bodyPr rtlCol="0" anchor="ctr" wrap="square" lIns="76200" rIns="76200" tIns="50800" bIns="50800"/>
+          <a:lstStyle/>
+          <a:p>
+            <a:pPr algn="ctr">
+              <a:defRPr sz="900" b="1">
+                <a:solidFill>
+                  <a:srgbClr val="E6E8EB"/>
+                </a:solidFill>
+                <a:latin typeface="Calibri"/>
+              </a:defRPr>
+            </a:pPr>
+            <a:r>
+              <a:t>IRIS</a:t>
+            </a:r>
+          </a:p>
+        </p:txBody>
+      </p:sp>
+      <p:sp>
+        <p:nvSpPr>
+          <p:cNvPr id="25" name="TextBox 24"/>
+          <p:cNvSpPr txBox="1"/>
+          <p:nvPr/>
+        </p:nvSpPr>
+        <p:spPr>
+          <a:xfrm>
+            <a:off x="960120" y="4069080"/>
+            <a:ext cx="2103120" cy="365760"/>
+          </a:xfrm>
+          <a:prstGeom prst="rect">
+            <a:avLst/>
+          </a:prstGeom>
+          <a:noFill/>
+        </p:spPr>
+        <p:txBody>
+          <a:bodyPr wrap="square">
+            <a:spAutoFit/>
+          </a:bodyPr>
+          <a:lstStyle/>
+          <a:p>
+            <a:pPr algn="l">
+              <a:defRPr sz="1600" b="1">
+                <a:solidFill>
+                  <a:srgbClr val="E6E8EB"/>
+                </a:solidFill>
+                <a:latin typeface="Calibri"/>
+              </a:defRPr>
+            </a:pPr>
+            <a:r>
+              <a:t>Platform Stickiness</a:t>
+            </a:r>
+          </a:p>
+        </p:txBody>
+      </p:sp>
+      <p:sp>
+        <p:nvSpPr>
+          <p:cNvPr id="26" name="TextBox 25"/>
+          <p:cNvSpPr txBox="1"/>
+          <p:nvPr/>
+        </p:nvSpPr>
+        <p:spPr>
+          <a:xfrm>
+            <a:off x="960120" y="4480560"/>
+            <a:ext cx="2926080" cy="1188720"/>
+          </a:xfrm>
+          <a:prstGeom prst="rect">
+            <a:avLst/>
+          </a:prstGeom>
+          <a:noFill/>
+        </p:spPr>
+        <p:txBody>
+          <a:bodyPr wrap="square">
+            <a:spAutoFit/>
+          </a:bodyPr>
+          <a:lstStyle/>
+          <a:p>
+            <a:pPr algn="l">
+              <a:defRPr sz="1100" b="0">
+                <a:solidFill>
+                  <a:srgbClr val="8B95A5"/>
+                </a:solidFill>
+                <a:latin typeface="Calibri"/>
+              </a:defRPr>
+            </a:pPr>
+            <a:r>
+              <a:t>AI assistance embedded in the integration engine is a compelling reason to choose and stay on IRIS for Health. No competitor offers this today.</a:t>
+            </a:r>
+          </a:p>
+        </p:txBody>
+      </p:sp>
+      <p:sp>
+        <p:nvSpPr>
+          <p:cNvPr id="27" name="Rounded Rectangle 26"/>
+          <p:cNvSpPr/>
+          <p:nvPr/>
+        </p:nvSpPr>
+        <p:spPr>
+          <a:xfrm>
+            <a:off x="960120" y="5806440"/>
+            <a:ext cx="1371600" cy="274320"/>
+          </a:xfrm>
+          <a:prstGeom prst="roundRect">
+            <a:avLst/>
+          </a:prstGeom>
+          <a:solidFill>
+            <a:srgbClr val="007BC0"/>
+          </a:solidFill>
+          <a:ln>
+            <a:noFill/>
+          </a:ln>
+        </p:spPr>
+        <p:style>
+          <a:lnRef idx="1">
+            <a:schemeClr val="accent1"/>
+          </a:lnRef>
+          <a:fillRef idx="3">
+            <a:schemeClr val="accent1"/>
+          </a:fillRef>
+          <a:effectRef idx="2">
+            <a:schemeClr val="accent1"/>
+          </a:effectRef>
+          <a:fontRef idx="minor">
+            <a:schemeClr val="lt1"/>
+          </a:fontRef>
+        </p:style>
+        <p:txBody>
+          <a:bodyPr rtlCol="0" anchor="ctr" wrap="square" lIns="76200" rIns="76200" tIns="50800" bIns="50800"/>
+          <a:lstStyle/>
+          <a:p>
+            <a:pPr algn="ctr">
+              <a:defRPr sz="1000" b="1">
+                <a:solidFill>
+                  <a:srgbClr val="E6E8EB"/>
+                </a:solidFill>
+                <a:latin typeface="Calibri"/>
+              </a:defRPr>
+            </a:pPr>
+            <a:r>
+              <a:t>Unique to IRIS</a:t>
+            </a:r>
+          </a:p>
+        </p:txBody>
+      </p:sp>
+      <p:sp>
+        <p:nvSpPr>
+          <p:cNvPr id="28" name="Rounded Rectangle 27"/>
+          <p:cNvSpPr/>
+          <p:nvPr/>
+        </p:nvSpPr>
+        <p:spPr>
+          <a:xfrm>
+            <a:off x="4434840" y="3931920"/>
+            <a:ext cx="3383280" cy="2331720"/>
+          </a:xfrm>
+          <a:prstGeom prst="roundRect">
+            <a:avLst/>
+          </a:prstGeom>
+          <a:solidFill>
+            <a:srgbClr val="13171E"/>
+          </a:solidFill>
+          <a:ln>
+            <a:noFill/>
+          </a:ln>
+        </p:spPr>
+        <p:style>
+          <a:lnRef idx="1">
+            <a:schemeClr val="accent1"/>
+          </a:lnRef>
+          <a:fillRef idx="3">
+            <a:schemeClr val="accent1"/>
+          </a:fillRef>
+          <a:effectRef idx="2">
+            <a:schemeClr val="accent1"/>
+          </a:effectRef>
+          <a:fontRef idx="minor">
+            <a:schemeClr val="lt1"/>
+          </a:fontRef>
+        </p:style>
+        <p:txBody>
+          <a:bodyPr rtlCol="0" anchor="ctr"/>
+          <a:lstStyle/>
+          <a:p>
+            <a:pPr algn="ctr"/>
+          </a:p>
+        </p:txBody>
+      </p:sp>
+      <p:sp>
+        <p:nvSpPr>
+          <p:cNvPr id="29" name="Rectangle 28"/>
+          <p:cNvSpPr/>
+          <p:nvPr/>
+        </p:nvSpPr>
+        <p:spPr>
+          <a:xfrm>
+            <a:off x="4434840" y="3931920"/>
+            <a:ext cx="63500" cy="2331720"/>
+          </a:xfrm>
+          <a:prstGeom prst="rect">
+            <a:avLst/>
+          </a:prstGeom>
+          <a:solidFill>
+            <a:srgbClr val="7C3AED"/>
+          </a:solidFill>
+          <a:ln>
+            <a:noFill/>
+          </a:ln>
+        </p:spPr>
+        <p:style>
+          <a:lnRef idx="1">
+            <a:schemeClr val="accent1"/>
+          </a:lnRef>
+          <a:fillRef idx="3">
+            <a:schemeClr val="accent1"/>
+          </a:fillRef>
+          <a:effectRef idx="2">
+            <a:schemeClr val="accent1"/>
+          </a:effectRef>
+          <a:fontRef idx="minor">
+            <a:schemeClr val="lt1"/>
+          </a:fontRef>
+        </p:style>
+        <p:txBody>
+          <a:bodyPr rtlCol="0" anchor="ctr"/>
+          <a:lstStyle/>
+          <a:p>
+            <a:pPr algn="ctr"/>
+          </a:p>
+        </p:txBody>
+      </p:sp>
+      <p:sp>
+        <p:nvSpPr>
+          <p:cNvPr id="30" name="Rounded Rectangle 29"/>
+          <p:cNvSpPr/>
+          <p:nvPr/>
+        </p:nvSpPr>
+        <p:spPr>
+          <a:xfrm>
+            <a:off x="6858000" y="4069080"/>
+            <a:ext cx="822960" cy="502920"/>
+          </a:xfrm>
+          <a:prstGeom prst="roundRect">
+            <a:avLst/>
+          </a:prstGeom>
+          <a:solidFill>
+            <a:srgbClr val="7C3AED"/>
+          </a:solidFill>
+          <a:ln>
+            <a:noFill/>
+          </a:ln>
+        </p:spPr>
+        <p:style>
+          <a:lnRef idx="1">
+            <a:schemeClr val="accent1"/>
+          </a:lnRef>
+          <a:fillRef idx="3">
+            <a:schemeClr val="accent1"/>
+          </a:fillRef>
+          <a:effectRef idx="2">
+            <a:schemeClr val="accent1"/>
+          </a:effectRef>
+          <a:fontRef idx="minor">
+            <a:schemeClr val="lt1"/>
+          </a:fontRef>
+        </p:style>
+        <p:txBody>
+          <a:bodyPr rtlCol="0" anchor="ctr" wrap="square" lIns="76200" rIns="76200" tIns="50800" bIns="50800"/>
+          <a:lstStyle/>
+          <a:p>
+            <a:pPr algn="ctr">
+              <a:defRPr sz="900" b="1">
+                <a:solidFill>
+                  <a:srgbClr val="E6E8EB"/>
+                </a:solidFill>
+                <a:latin typeface="Calibri"/>
+              </a:defRPr>
+            </a:pPr>
+            <a:r>
+              <a:t>1+1=3</a:t>
+            </a:r>
+          </a:p>
+        </p:txBody>
+      </p:sp>
+      <p:sp>
+        <p:nvSpPr>
+          <p:cNvPr id="31" name="TextBox 30"/>
+          <p:cNvSpPr txBox="1"/>
+          <p:nvPr/>
+        </p:nvSpPr>
+        <p:spPr>
+          <a:xfrm>
+            <a:off x="4663440" y="4069080"/>
+            <a:ext cx="2103120" cy="365760"/>
+          </a:xfrm>
+          <a:prstGeom prst="rect">
+            <a:avLst/>
+          </a:prstGeom>
+          <a:noFill/>
+        </p:spPr>
+        <p:txBody>
+          <a:bodyPr wrap="square">
+            <a:spAutoFit/>
+          </a:bodyPr>
+          <a:lstStyle/>
+          <a:p>
+            <a:pPr algn="l">
+              <a:defRPr sz="1600" b="1">
+                <a:solidFill>
+                  <a:srgbClr val="E6E8EB"/>
+                </a:solidFill>
+                <a:latin typeface="Calibri"/>
+              </a:defRPr>
+            </a:pPr>
+            <a:r>
+              <a:t>Community Flywheel</a:t>
+            </a:r>
+          </a:p>
+        </p:txBody>
+      </p:sp>
+      <p:sp>
+        <p:nvSpPr>
+          <p:cNvPr id="32" name="TextBox 31"/>
+          <p:cNvSpPr txBox="1"/>
+          <p:nvPr/>
+        </p:nvSpPr>
+        <p:spPr>
+          <a:xfrm>
+            <a:off x="4663440" y="4480560"/>
+            <a:ext cx="2926080" cy="1188720"/>
+          </a:xfrm>
+          <a:prstGeom prst="rect">
+            <a:avLst/>
+          </a:prstGeom>
+          <a:noFill/>
+        </p:spPr>
+        <p:txBody>
+          <a:bodyPr wrap="square">
+            <a:spAutoFit/>
+          </a:bodyPr>
+          <a:lstStyle/>
+          <a:p>
+            <a:pPr algn="l">
+              <a:defRPr sz="1100" b="0">
+                <a:solidFill>
+                  <a:srgbClr val="8B95A5"/>
+                </a:solidFill>
+                <a:latin typeface="Calibri"/>
+              </a:defRPr>
+            </a:pPr>
+            <a:r>
+              <a:t>Every custom tool, skill, and agent built by customers, SEs, and ISVs benefits the entire ecosystem. Content compounds; the platform gets smarter over time.</a:t>
+            </a:r>
+          </a:p>
+        </p:txBody>
+      </p:sp>
+      <p:sp>
+        <p:nvSpPr>
+          <p:cNvPr id="33" name="Rounded Rectangle 32"/>
+          <p:cNvSpPr/>
+          <p:nvPr/>
+        </p:nvSpPr>
+        <p:spPr>
+          <a:xfrm>
+            <a:off x="4663440" y="5806440"/>
+            <a:ext cx="1371600" cy="274320"/>
+          </a:xfrm>
+          <a:prstGeom prst="roundRect">
+            <a:avLst/>
+          </a:prstGeom>
+          <a:solidFill>
+            <a:srgbClr val="7C3AED"/>
+          </a:solidFill>
+          <a:ln>
+            <a:noFill/>
+          </a:ln>
+        </p:spPr>
+        <p:style>
+          <a:lnRef idx="1">
+            <a:schemeClr val="accent1"/>
+          </a:lnRef>
+          <a:fillRef idx="3">
+            <a:schemeClr val="accent1"/>
+          </a:fillRef>
+          <a:effectRef idx="2">
+            <a:schemeClr val="accent1"/>
+          </a:effectRef>
+          <a:fontRef idx="minor">
+            <a:schemeClr val="lt1"/>
+          </a:fontRef>
+        </p:style>
+        <p:txBody>
+          <a:bodyPr rtlCol="0" anchor="ctr" wrap="square" lIns="76200" rIns="76200" tIns="50800" bIns="50800"/>
+          <a:lstStyle/>
+          <a:p>
+            <a:pPr algn="ctr">
+              <a:defRPr sz="1000" b="1">
+                <a:solidFill>
+                  <a:srgbClr val="E6E8EB"/>
+                </a:solidFill>
+                <a:latin typeface="Calibri"/>
+              </a:defRPr>
+            </a:pPr>
+            <a:r>
+              <a:t>Network effects</a:t>
+            </a:r>
+          </a:p>
+        </p:txBody>
+      </p:sp>
+      <p:sp>
+        <p:nvSpPr>
+          <p:cNvPr id="34" name="Rounded Rectangle 33"/>
+          <p:cNvSpPr/>
+          <p:nvPr/>
+        </p:nvSpPr>
+        <p:spPr>
+          <a:xfrm>
+            <a:off x="8138160" y="3931920"/>
+            <a:ext cx="3383280" cy="2331720"/>
+          </a:xfrm>
+          <a:prstGeom prst="roundRect">
+            <a:avLst/>
+          </a:prstGeom>
+          <a:solidFill>
+            <a:srgbClr val="13171E"/>
+          </a:solidFill>
+          <a:ln>
+            <a:noFill/>
+          </a:ln>
+        </p:spPr>
+        <p:style>
+          <a:lnRef idx="1">
+            <a:schemeClr val="accent1"/>
+          </a:lnRef>
+          <a:fillRef idx="3">
+            <a:schemeClr val="accent1"/>
+          </a:fillRef>
+          <a:effectRef idx="2">
+            <a:schemeClr val="accent1"/>
+          </a:effectRef>
+          <a:fontRef idx="minor">
+            <a:schemeClr val="lt1"/>
+          </a:fontRef>
+        </p:style>
+        <p:txBody>
+          <a:bodyPr rtlCol="0" anchor="ctr"/>
+          <a:lstStyle/>
+          <a:p>
+            <a:pPr algn="ctr"/>
+          </a:p>
+        </p:txBody>
+      </p:sp>
+      <p:sp>
+        <p:nvSpPr>
+          <p:cNvPr id="35" name="Rectangle 34"/>
+          <p:cNvSpPr/>
+          <p:nvPr/>
+        </p:nvSpPr>
+        <p:spPr>
+          <a:xfrm>
+            <a:off x="8138160" y="3931920"/>
+            <a:ext cx="63500" cy="2331720"/>
+          </a:xfrm>
+          <a:prstGeom prst="rect">
+            <a:avLst/>
+          </a:prstGeom>
+          <a:solidFill>
+            <a:srgbClr val="F59E0B"/>
+          </a:solidFill>
+          <a:ln>
+            <a:noFill/>
+          </a:ln>
+        </p:spPr>
+        <p:style>
+          <a:lnRef idx="1">
+            <a:schemeClr val="accent1"/>
+          </a:lnRef>
+          <a:fillRef idx="3">
+            <a:schemeClr val="accent1"/>
+          </a:fillRef>
+          <a:effectRef idx="2">
+            <a:schemeClr val="accent1"/>
+          </a:effectRef>
+          <a:fontRef idx="minor">
+            <a:schemeClr val="lt1"/>
+          </a:fontRef>
+        </p:style>
+        <p:txBody>
+          <a:bodyPr rtlCol="0" anchor="ctr"/>
+          <a:lstStyle/>
+          <a:p>
+            <a:pPr algn="ctr"/>
+          </a:p>
+        </p:txBody>
+      </p:sp>
+      <p:sp>
+        <p:nvSpPr>
+          <p:cNvPr id="36" name="Rounded Rectangle 35"/>
+          <p:cNvSpPr/>
+          <p:nvPr/>
+        </p:nvSpPr>
+        <p:spPr>
+          <a:xfrm>
+            <a:off x="10561320" y="4069080"/>
+            <a:ext cx="822960" cy="502920"/>
+          </a:xfrm>
+          <a:prstGeom prst="roundRect">
+            <a:avLst/>
+          </a:prstGeom>
+          <a:solidFill>
+            <a:srgbClr val="F59E0B"/>
+          </a:solidFill>
+          <a:ln>
+            <a:noFill/>
+          </a:ln>
+        </p:spPr>
+        <p:style>
+          <a:lnRef idx="1">
+            <a:schemeClr val="accent1"/>
+          </a:lnRef>
+          <a:fillRef idx="3">
+            <a:schemeClr val="accent1"/>
+          </a:fillRef>
+          <a:effectRef idx="2">
+            <a:schemeClr val="accent1"/>
+          </a:effectRef>
+          <a:fontRef idx="minor">
+            <a:schemeClr val="lt1"/>
+          </a:fontRef>
+        </p:style>
+        <p:txBody>
+          <a:bodyPr rtlCol="0" anchor="ctr" wrap="square" lIns="76200" rIns="76200" tIns="50800" bIns="50800"/>
+          <a:lstStyle/>
+          <a:p>
+            <a:pPr algn="ctr">
+              <a:defRPr sz="900" b="1">
+                <a:solidFill>
+                  <a:srgbClr val="E6E8EB"/>
+                </a:solidFill>
+                <a:latin typeface="Calibri"/>
+              </a:defRPr>
+            </a:pPr>
+            <a:r>
+              <a:t>ONLY</a:t>
+            </a:r>
+            <a:br/>
+            <a:r>
+              <a:t>ONE</a:t>
+            </a:r>
+          </a:p>
+        </p:txBody>
+      </p:sp>
+      <p:sp>
+        <p:nvSpPr>
+          <p:cNvPr id="37" name="TextBox 36"/>
+          <p:cNvSpPr txBox="1"/>
+          <p:nvPr/>
+        </p:nvSpPr>
+        <p:spPr>
+          <a:xfrm>
+            <a:off x="8366760" y="4069080"/>
+            <a:ext cx="2103120" cy="365760"/>
+          </a:xfrm>
+          <a:prstGeom prst="rect">
+            <a:avLst/>
+          </a:prstGeom>
+          <a:noFill/>
+        </p:spPr>
+        <p:txBody>
+          <a:bodyPr wrap="square">
+            <a:spAutoFit/>
+          </a:bodyPr>
+          <a:lstStyle/>
+          <a:p>
+            <a:pPr algn="l">
+              <a:defRPr sz="1600" b="1">
+                <a:solidFill>
+                  <a:srgbClr val="E6E8EB"/>
+                </a:solidFill>
+                <a:latin typeface="Calibri"/>
+              </a:defRPr>
+            </a:pPr>
+            <a:r>
+              <a:t>Market Differentiator</a:t>
+            </a:r>
+          </a:p>
+        </p:txBody>
+      </p:sp>
+      <p:sp>
+        <p:nvSpPr>
+          <p:cNvPr id="38" name="TextBox 37"/>
+          <p:cNvSpPr txBox="1"/>
+          <p:nvPr/>
+        </p:nvSpPr>
+        <p:spPr>
+          <a:xfrm>
+            <a:off x="8366760" y="4480560"/>
+            <a:ext cx="2926080" cy="1188720"/>
+          </a:xfrm>
+          <a:prstGeom prst="rect">
+            <a:avLst/>
+          </a:prstGeom>
+          <a:noFill/>
+        </p:spPr>
+        <p:txBody>
+          <a:bodyPr wrap="square">
+            <a:spAutoFit/>
+          </a:bodyPr>
+          <a:lstStyle/>
+          <a:p>
+            <a:pPr algn="l">
+              <a:defRPr sz="1100" b="0">
+                <a:solidFill>
+                  <a:srgbClr val="8B95A5"/>
+                </a:solidFill>
+                <a:latin typeface="Calibri"/>
+              </a:defRPr>
+            </a:pPr>
+            <a:r>
+              <a:t>No other integration platform ships an AI framework with domain-specific healthcare tools. This is a first-mover advantage in the agentic AI era.</a:t>
+            </a:r>
+          </a:p>
+        </p:txBody>
+      </p:sp>
+      <p:sp>
+        <p:nvSpPr>
+          <p:cNvPr id="39" name="Rounded Rectangle 38"/>
+          <p:cNvSpPr/>
+          <p:nvPr/>
+        </p:nvSpPr>
+        <p:spPr>
+          <a:xfrm>
+            <a:off x="8366760" y="5806440"/>
+            <a:ext cx="1371600" cy="274320"/>
+          </a:xfrm>
+          <a:prstGeom prst="roundRect">
+            <a:avLst/>
+          </a:prstGeom>
+          <a:solidFill>
+            <a:srgbClr val="F59E0B"/>
+          </a:solidFill>
+          <a:ln>
+            <a:noFill/>
+          </a:ln>
+        </p:spPr>
+        <p:style>
+          <a:lnRef idx="1">
+            <a:schemeClr val="accent1"/>
+          </a:lnRef>
+          <a:fillRef idx="3">
+            <a:schemeClr val="accent1"/>
+          </a:fillRef>
+          <a:effectRef idx="2">
+            <a:schemeClr val="accent1"/>
+          </a:effectRef>
+          <a:fontRef idx="minor">
+            <a:schemeClr val="lt1"/>
+          </a:fontRef>
+        </p:style>
+        <p:txBody>
+          <a:bodyPr rtlCol="0" anchor="ctr" wrap="square" lIns="76200" rIns="76200" tIns="50800" bIns="50800"/>
+          <a:lstStyle/>
+          <a:p>
+            <a:pPr algn="ctr">
+              <a:defRPr sz="1000" b="1">
+                <a:solidFill>
+                  <a:srgbClr val="E6E8EB"/>
+                </a:solidFill>
+                <a:latin typeface="Calibri"/>
+              </a:defRPr>
+            </a:pPr>
+            <a:r>
+              <a:t>First in market</a:t>
+            </a:r>
+          </a:p>
+        </p:txBody>
+      </p:sp>
+    </p:spTree>
+  </p:cSld>
+  <p:clrMapOvr>
+    <a:masterClrMapping/>
+  </p:clrMapOvr>
+</p:sld>
+</file>
+
+<file path=ppt/slides/slide8.xml><?xml version="1.0" encoding="utf-8"?>
+<p:sld xmlns:a="http://schemas.openxmlformats.org/drawingml/2006/main" xmlns:p="http://schemas.openxmlformats.org/presentationml/2006/main" xmlns:r="http://schemas.openxmlformats.org/officeDocument/2006/relationships">
+  <p:cSld>
+    <p:bg>
+      <p:bgPr>
+        <a:solidFill>
+          <a:srgbClr val="0B0D11"/>
+        </a:solidFill>
+        <a:effectLst/>
+      </p:bgPr>
+    </p:bg>
+    <p:spTree>
+      <p:nvGrpSpPr>
+        <p:cNvPr id="1" name=""/>
+        <p:cNvGrpSpPr/>
+        <p:nvPr/>
+      </p:nvGrpSpPr>
+      <p:grpSpPr/>
+      <p:sp>
+        <p:nvSpPr>
+          <p:cNvPr id="2" name="TextBox 1"/>
+          <p:cNvSpPr txBox="1"/>
+          <p:nvPr/>
+        </p:nvSpPr>
+        <p:spPr>
+          <a:xfrm>
+            <a:off x="731520" y="365760"/>
+            <a:ext cx="10058400" cy="640080"/>
+          </a:xfrm>
+          <a:prstGeom prst="rect">
+            <a:avLst/>
+          </a:prstGeom>
+          <a:noFill/>
+        </p:spPr>
+        <p:txBody>
+          <a:bodyPr wrap="square">
+            <a:spAutoFit/>
+          </a:bodyPr>
+          <a:lstStyle/>
+          <a:p>
+            <a:pPr algn="l">
+              <a:defRPr sz="3200" b="1">
+                <a:solidFill>
+                  <a:srgbClr val="E6E8EB"/>
+                </a:solidFill>
+                <a:latin typeface="Calibri"/>
+              </a:defRPr>
+            </a:pPr>
+            <a:r>
+              <a:t>Next Steps</a:t>
+            </a:r>
+          </a:p>
+        </p:txBody>
+      </p:sp>
+      <p:sp>
+        <p:nvSpPr>
+          <p:cNvPr id="3" name="Rectangle 2"/>
+          <p:cNvSpPr/>
+          <p:nvPr/>
+        </p:nvSpPr>
+        <p:spPr>
+          <a:xfrm>
+            <a:off x="731520" y="868680"/>
+            <a:ext cx="1828800" cy="38100"/>
+          </a:xfrm>
+          <a:prstGeom prst="rect">
+            <a:avLst/>
+          </a:prstGeom>
+          <a:solidFill>
+            <a:srgbClr val="606FF3"/>
+          </a:solidFill>
+          <a:ln>
+            <a:noFill/>
+          </a:ln>
+        </p:spPr>
+        <p:style>
+          <a:lnRef idx="1">
+            <a:schemeClr val="accent1"/>
+          </a:lnRef>
+          <a:fillRef idx="3">
+            <a:schemeClr val="accent1"/>
+          </a:fillRef>
+          <a:effectRef idx="2">
+            <a:schemeClr val="accent1"/>
+          </a:effectRef>
+          <a:fontRef idx="minor">
+            <a:schemeClr val="lt1"/>
+          </a:fontRef>
+        </p:style>
+        <p:txBody>
+          <a:bodyPr rtlCol="0" anchor="ctr"/>
+          <a:lstStyle/>
+          <a:p>
+            <a:pPr algn="ctr"/>
+          </a:p>
+        </p:txBody>
+      </p:sp>
+      <p:sp>
+        <p:nvSpPr>
+          <p:cNvPr id="4" name="Rounded Rectangle 3"/>
+          <p:cNvSpPr/>
+          <p:nvPr/>
+        </p:nvSpPr>
+        <p:spPr>
+          <a:xfrm>
+            <a:off x="731520" y="1645920"/>
+            <a:ext cx="3383280" cy="3474720"/>
+          </a:xfrm>
+          <a:prstGeom prst="roundRect">
+            <a:avLst/>
+          </a:prstGeom>
+          <a:solidFill>
+            <a:srgbClr val="13171E"/>
+          </a:solidFill>
+          <a:ln>
+            <a:noFill/>
+          </a:ln>
+        </p:spPr>
+        <p:style>
+          <a:lnRef idx="1">
+            <a:schemeClr val="accent1"/>
+          </a:lnRef>
+          <a:fillRef idx="3">
+            <a:schemeClr val="accent1"/>
+          </a:fillRef>
+          <a:effectRef idx="2">
+            <a:schemeClr val="accent1"/>
+          </a:effectRef>
+          <a:fontRef idx="minor">
+            <a:schemeClr val="lt1"/>
+          </a:fontRef>
+        </p:style>
+        <p:txBody>
+          <a:bodyPr rtlCol="0" anchor="ctr"/>
+          <a:lstStyle/>
+          <a:p>
+            <a:pPr algn="ctr"/>
+          </a:p>
+        </p:txBody>
+      </p:sp>
+      <p:sp>
+        <p:nvSpPr>
+          <p:cNvPr id="5" name="Rectangle 4"/>
+          <p:cNvSpPr/>
+          <p:nvPr/>
+        </p:nvSpPr>
+        <p:spPr>
+          <a:xfrm>
+            <a:off x="731520" y="1645920"/>
+            <a:ext cx="3383280" cy="63500"/>
+          </a:xfrm>
+          <a:prstGeom prst="rect">
+            <a:avLst/>
+          </a:prstGeom>
+          <a:solidFill>
+            <a:srgbClr val="14B8A6"/>
+          </a:solidFill>
+          <a:ln>
+            <a:noFill/>
+          </a:ln>
+        </p:spPr>
+        <p:style>
+          <a:lnRef idx="1">
+            <a:schemeClr val="accent1"/>
+          </a:lnRef>
+          <a:fillRef idx="3">
+            <a:schemeClr val="accent1"/>
+          </a:fillRef>
+          <a:effectRef idx="2">
+            <a:schemeClr val="accent1"/>
+          </a:effectRef>
+          <a:fontRef idx="minor">
+            <a:schemeClr val="lt1"/>
+          </a:fontRef>
+        </p:style>
+        <p:txBody>
+          <a:bodyPr rtlCol="0" anchor="ctr"/>
+          <a:lstStyle/>
+          <a:p>
+            <a:pPr algn="ctr"/>
+          </a:p>
+        </p:txBody>
+      </p:sp>
+      <p:sp>
+        <p:nvSpPr>
+          <p:cNvPr id="6" name="Rounded Rectangle 5"/>
+          <p:cNvSpPr/>
+          <p:nvPr/>
+        </p:nvSpPr>
+        <p:spPr>
+          <a:xfrm>
+            <a:off x="960120" y="1874520"/>
+            <a:ext cx="457200" cy="457200"/>
+          </a:xfrm>
+          <a:prstGeom prst="roundRect">
+            <a:avLst/>
+          </a:prstGeom>
+          <a:solidFill>
+            <a:srgbClr val="14B8A6"/>
+          </a:solidFill>
+          <a:ln>
+            <a:noFill/>
+          </a:ln>
+        </p:spPr>
+        <p:style>
+          <a:lnRef idx="1">
+            <a:schemeClr val="accent1"/>
+          </a:lnRef>
+          <a:fillRef idx="3">
+            <a:schemeClr val="accent1"/>
+          </a:fillRef>
+          <a:effectRef idx="2">
+            <a:schemeClr val="accent1"/>
+          </a:effectRef>
+          <a:fontRef idx="minor">
+            <a:schemeClr val="lt1"/>
+          </a:fontRef>
+        </p:style>
+        <p:txBody>
+          <a:bodyPr rtlCol="0" anchor="ctr" wrap="square" lIns="76200" rIns="76200" tIns="50800" bIns="50800"/>
+          <a:lstStyle/>
+          <a:p>
+            <a:pPr algn="ctr">
+              <a:defRPr sz="1600" b="1">
+                <a:solidFill>
+                  <a:srgbClr val="E6E8EB"/>
+                </a:solidFill>
+                <a:latin typeface="Calibri"/>
+              </a:defRPr>
+            </a:pPr>
+            <a:r>
+              <a:t>1</a:t>
+            </a:r>
+          </a:p>
+        </p:txBody>
+      </p:sp>
+      <p:sp>
+        <p:nvSpPr>
+          <p:cNvPr id="7" name="TextBox 6"/>
+          <p:cNvSpPr txBox="1"/>
+          <p:nvPr/>
+        </p:nvSpPr>
+        <p:spPr>
+          <a:xfrm>
+            <a:off x="1554480" y="1874520"/>
+            <a:ext cx="2286000" cy="320040"/>
+          </a:xfrm>
+          <a:prstGeom prst="rect">
+            <a:avLst/>
+          </a:prstGeom>
+          <a:noFill/>
+        </p:spPr>
+        <p:txBody>
+          <a:bodyPr wrap="square">
+            <a:spAutoFit/>
+          </a:bodyPr>
+          <a:lstStyle/>
+          <a:p>
+            <a:pPr algn="l">
+              <a:defRPr sz="1400" b="1">
+                <a:solidFill>
+                  <a:srgbClr val="14B8A6"/>
+                </a:solidFill>
+                <a:latin typeface="Calibri"/>
+              </a:defRPr>
+            </a:pPr>
+            <a:r>
+              <a:t>Immediate</a:t>
+            </a:r>
+          </a:p>
+        </p:txBody>
+      </p:sp>
+      <p:sp>
+        <p:nvSpPr>
+          <p:cNvPr id="8" name="TextBox 7"/>
+          <p:cNvSpPr txBox="1"/>
+          <p:nvPr/>
+        </p:nvSpPr>
+        <p:spPr>
+          <a:xfrm>
+            <a:off x="1554480" y="2148840"/>
+            <a:ext cx="2286000" cy="274320"/>
+          </a:xfrm>
+          <a:prstGeom prst="rect">
+            <a:avLst/>
+          </a:prstGeom>
+          <a:noFill/>
+        </p:spPr>
+        <p:txBody>
+          <a:bodyPr wrap="square">
+            <a:spAutoFit/>
+          </a:bodyPr>
+          <a:lstStyle/>
+          <a:p>
+            <a:pPr algn="l">
+              <a:defRPr sz="1800" b="1">
+                <a:solidFill>
+                  <a:srgbClr val="E6E8EB"/>
+                </a:solidFill>
+                <a:latin typeface="Calibri"/>
+              </a:defRPr>
+            </a:pPr>
+            <a:r>
+              <a:t>Fix &amp; Ship</a:t>
+            </a:r>
+          </a:p>
+        </p:txBody>
+      </p:sp>
+      <p:sp>
+        <p:nvSpPr>
+          <p:cNvPr id="9" name="TextBox 8"/>
+          <p:cNvSpPr txBox="1"/>
+          <p:nvPr/>
+        </p:nvSpPr>
+        <p:spPr>
+          <a:xfrm>
+            <a:off x="960120" y="2651760"/>
+            <a:ext cx="2926080" cy="2286000"/>
+          </a:xfrm>
+          <a:prstGeom prst="rect">
+            <a:avLst/>
+          </a:prstGeom>
+          <a:noFill/>
+        </p:spPr>
+        <p:txBody>
+          <a:bodyPr wrap="square">
+            <a:spAutoFit/>
+          </a:bodyPr>
+          <a:lstStyle/>
+          <a:p>
+            <a:pPr algn="l">
+              <a:defRPr sz="1300" b="0">
+                <a:solidFill>
+                  <a:srgbClr val="E6E8EB"/>
+                </a:solidFill>
+                <a:latin typeface="Calibri"/>
+              </a:defRPr>
+            </a:pPr>
           </a:p>
           <a:p>
             <a:pPr>
               <a:spcBef>
                 <a:spcPts val="400"/>
               </a:spcBef>
-              <a:defRPr sz="1500" b="0">
-                <a:solidFill>
-                  <a:srgbClr val="E6E8EB"/>
-                </a:solidFill>
-                <a:latin typeface="Calibri"/>
-              </a:defRPr>
-            </a:pPr>
-            <a:r>
-              <a:t>Faster time-to-value: engineers build productions in minutes instead of days</a:t>
+              <a:defRPr sz="1300" b="0">
+                <a:solidFill>
+                  <a:srgbClr val="8B95A5"/>
+                </a:solidFill>
+                <a:latin typeface="Calibri"/>
+              </a:defRPr>
+            </a:pPr>
+            <a:r>
+              <a:t>Fix 2 blocker bugs (Skill $ZF, Bedrock hang)</a:t>
             </a:r>
           </a:p>
           <a:p>
@@ -6796,15 +8706,15 @@
               <a:spcBef>
                 <a:spcPts val="400"/>
               </a:spcBef>
-              <a:defRPr sz="1500" b="0">
-                <a:solidFill>
-                  <a:srgbClr val="E6E8EB"/>
-                </a:solidFill>
-                <a:latin typeface="Calibri"/>
-              </a:defRPr>
-            </a:pPr>
-            <a:r>
-              <a:t>Lower barrier to entry: new engineers productive from day one with natural-language guidance</a:t>
+              <a:defRPr sz="1300" b="0">
+                <a:solidFill>
+                  <a:srgbClr val="8B95A5"/>
+                </a:solidFill>
+                <a:latin typeface="Calibri"/>
+              </a:defRPr>
+            </a:pPr>
+            <a:r>
+              <a:t>Ship ToolFilter as framework default</a:t>
             </a:r>
           </a:p>
           <a:p>
@@ -6812,7 +8722,146 @@
               <a:spcBef>
                 <a:spcPts val="400"/>
               </a:spcBef>
-              <a:defRPr sz="1500" b="0">
+              <a:defRPr sz="1300" b="0">
+                <a:solidFill>
+                  <a:srgbClr val="8B95A5"/>
+                </a:solidFill>
+                <a:latin typeface="Calibri"/>
+              </a:defRPr>
+            </a:pPr>
+            <a:r>
+              <a:t>Document %AI.ToolMgr.ExecuteTool path</a:t>
+            </a:r>
+          </a:p>
+        </p:txBody>
+      </p:sp>
+      <p:sp>
+        <p:nvSpPr>
+          <p:cNvPr id="10" name="Rounded Rectangle 9"/>
+          <p:cNvSpPr/>
+          <p:nvPr/>
+        </p:nvSpPr>
+        <p:spPr>
+          <a:xfrm>
+            <a:off x="4434840" y="1645920"/>
+            <a:ext cx="3383280" cy="3474720"/>
+          </a:xfrm>
+          <a:prstGeom prst="roundRect">
+            <a:avLst/>
+          </a:prstGeom>
+          <a:solidFill>
+            <a:srgbClr val="13171E"/>
+          </a:solidFill>
+          <a:ln>
+            <a:noFill/>
+          </a:ln>
+        </p:spPr>
+        <p:style>
+          <a:lnRef idx="1">
+            <a:schemeClr val="accent1"/>
+          </a:lnRef>
+          <a:fillRef idx="3">
+            <a:schemeClr val="accent1"/>
+          </a:fillRef>
+          <a:effectRef idx="2">
+            <a:schemeClr val="accent1"/>
+          </a:effectRef>
+          <a:fontRef idx="minor">
+            <a:schemeClr val="lt1"/>
+          </a:fontRef>
+        </p:style>
+        <p:txBody>
+          <a:bodyPr rtlCol="0" anchor="ctr"/>
+          <a:lstStyle/>
+          <a:p>
+            <a:pPr algn="ctr"/>
+          </a:p>
+        </p:txBody>
+      </p:sp>
+      <p:sp>
+        <p:nvSpPr>
+          <p:cNvPr id="11" name="Rectangle 10"/>
+          <p:cNvSpPr/>
+          <p:nvPr/>
+        </p:nvSpPr>
+        <p:spPr>
+          <a:xfrm>
+            <a:off x="4434840" y="1645920"/>
+            <a:ext cx="3383280" cy="63500"/>
+          </a:xfrm>
+          <a:prstGeom prst="rect">
+            <a:avLst/>
+          </a:prstGeom>
+          <a:solidFill>
+            <a:srgbClr val="F59E0B"/>
+          </a:solidFill>
+          <a:ln>
+            <a:noFill/>
+          </a:ln>
+        </p:spPr>
+        <p:style>
+          <a:lnRef idx="1">
+            <a:schemeClr val="accent1"/>
+          </a:lnRef>
+          <a:fillRef idx="3">
+            <a:schemeClr val="accent1"/>
+          </a:fillRef>
+          <a:effectRef idx="2">
+            <a:schemeClr val="accent1"/>
+          </a:effectRef>
+          <a:fontRef idx="minor">
+            <a:schemeClr val="lt1"/>
+          </a:fontRef>
+        </p:style>
+        <p:txBody>
+          <a:bodyPr rtlCol="0" anchor="ctr"/>
+          <a:lstStyle/>
+          <a:p>
+            <a:pPr algn="ctr"/>
+          </a:p>
+        </p:txBody>
+      </p:sp>
+      <p:sp>
+        <p:nvSpPr>
+          <p:cNvPr id="12" name="Rounded Rectangle 11"/>
+          <p:cNvSpPr/>
+          <p:nvPr/>
+        </p:nvSpPr>
+        <p:spPr>
+          <a:xfrm>
+            <a:off x="4663440" y="1874520"/>
+            <a:ext cx="457200" cy="457200"/>
+          </a:xfrm>
+          <a:prstGeom prst="roundRect">
+            <a:avLst/>
+          </a:prstGeom>
+          <a:solidFill>
+            <a:srgbClr val="F59E0B"/>
+          </a:solidFill>
+          <a:ln>
+            <a:noFill/>
+          </a:ln>
+        </p:spPr>
+        <p:style>
+          <a:lnRef idx="1">
+            <a:schemeClr val="accent1"/>
+          </a:lnRef>
+          <a:fillRef idx="3">
+            <a:schemeClr val="accent1"/>
+          </a:fillRef>
+          <a:effectRef idx="2">
+            <a:schemeClr val="accent1"/>
+          </a:effectRef>
+          <a:fontRef idx="minor">
+            <a:schemeClr val="lt1"/>
+          </a:fontRef>
+        </p:style>
+        <p:txBody>
+          <a:bodyPr rtlCol="0" anchor="ctr" wrap="square" lIns="76200" rIns="76200" tIns="50800" bIns="50800"/>
+          <a:lstStyle/>
+          <a:p>
+            <a:pPr algn="ctr">
+              <a:defRPr sz="1600" b="1">
                 <a:solidFill>
                   <a:srgbClr val="E6E8EB"/>
                 </a:solidFill>
@@ -6820,23 +8869,128 @@
               </a:defRPr>
             </a:pPr>
             <a:r>
-              <a:t>Higher quality: automated validation catches misconfigurations before they reach production</a:t>
-            </a:r>
+              <a:t>2</a:t>
+            </a:r>
+          </a:p>
+        </p:txBody>
+      </p:sp>
+      <p:sp>
+        <p:nvSpPr>
+          <p:cNvPr id="13" name="TextBox 12"/>
+          <p:cNvSpPr txBox="1"/>
+          <p:nvPr/>
+        </p:nvSpPr>
+        <p:spPr>
+          <a:xfrm>
+            <a:off x="5257800" y="1874520"/>
+            <a:ext cx="2286000" cy="320040"/>
+          </a:xfrm>
+          <a:prstGeom prst="rect">
+            <a:avLst/>
+          </a:prstGeom>
+          <a:noFill/>
+        </p:spPr>
+        <p:txBody>
+          <a:bodyPr wrap="square">
+            <a:spAutoFit/>
+          </a:bodyPr>
+          <a:lstStyle/>
+          <a:p>
+            <a:pPr algn="l">
+              <a:defRPr sz="1400" b="1">
+                <a:solidFill>
+                  <a:srgbClr val="F59E0B"/>
+                </a:solidFill>
+                <a:latin typeface="Calibri"/>
+              </a:defRPr>
+            </a:pPr>
+            <a:r>
+              <a:t>Q3-Q4 2026</a:t>
+            </a:r>
+          </a:p>
+        </p:txBody>
+      </p:sp>
+      <p:sp>
+        <p:nvSpPr>
+          <p:cNvPr id="14" name="TextBox 13"/>
+          <p:cNvSpPr txBox="1"/>
+          <p:nvPr/>
+        </p:nvSpPr>
+        <p:spPr>
+          <a:xfrm>
+            <a:off x="5257800" y="2148840"/>
+            <a:ext cx="2286000" cy="274320"/>
+          </a:xfrm>
+          <a:prstGeom prst="rect">
+            <a:avLst/>
+          </a:prstGeom>
+          <a:noFill/>
+        </p:spPr>
+        <p:txBody>
+          <a:bodyPr wrap="square">
+            <a:spAutoFit/>
+          </a:bodyPr>
+          <a:lstStyle/>
+          <a:p>
+            <a:pPr algn="l">
+              <a:defRPr sz="1800" b="1">
+                <a:solidFill>
+                  <a:srgbClr val="E6E8EB"/>
+                </a:solidFill>
+                <a:latin typeface="Calibri"/>
+              </a:defRPr>
+            </a:pPr>
+            <a:r>
+              <a:t>Field Trial</a:t>
+            </a:r>
+          </a:p>
+        </p:txBody>
+      </p:sp>
+      <p:sp>
+        <p:nvSpPr>
+          <p:cNvPr id="15" name="TextBox 14"/>
+          <p:cNvSpPr txBox="1"/>
+          <p:nvPr/>
+        </p:nvSpPr>
+        <p:spPr>
+          <a:xfrm>
+            <a:off x="4663440" y="2651760"/>
+            <a:ext cx="2926080" cy="2286000"/>
+          </a:xfrm>
+          <a:prstGeom prst="rect">
+            <a:avLst/>
+          </a:prstGeom>
+          <a:noFill/>
+        </p:spPr>
+        <p:txBody>
+          <a:bodyPr wrap="square">
+            <a:spAutoFit/>
+          </a:bodyPr>
+          <a:lstStyle/>
+          <a:p>
+            <a:pPr algn="l">
+              <a:defRPr sz="1300" b="0">
+                <a:solidFill>
+                  <a:srgbClr val="E6E8EB"/>
+                </a:solidFill>
+                <a:latin typeface="Calibri"/>
+              </a:defRPr>
+            </a:pPr>
           </a:p>
           <a:p>
             <a:pPr>
               <a:spcBef>
                 <a:spcPts val="400"/>
               </a:spcBef>
-              <a:defRPr sz="1500" b="0">
-                <a:solidFill>
-                  <a:srgbClr val="E6E8EB"/>
-                </a:solidFill>
-                <a:latin typeface="Calibri"/>
-              </a:defRPr>
-            </a:pPr>
-            <a:r>
-              <a:t>Platform stickiness: AI assistance is a compelling reason to stay on IRIS for Health</a:t>
+              <a:defRPr sz="1300" b="0">
+                <a:solidFill>
+                  <a:srgbClr val="8B95A5"/>
+                </a:solidFill>
+                <a:latin typeface="Calibri"/>
+              </a:defRPr>
+            </a:pPr>
+            <a:r>
+              <a:t>Package as IPM for 3 customer pilots</a:t>
             </a:r>
           </a:p>
           <a:p>
@@ -6844,15 +8998,15 @@
               <a:spcBef>
                 <a:spcPts val="400"/>
               </a:spcBef>
-              <a:defRPr sz="1500" b="0">
-                <a:solidFill>
-                  <a:srgbClr val="E6E8EB"/>
-                </a:solidFill>
-                <a:latin typeface="Calibri"/>
-              </a:defRPr>
-            </a:pPr>
-            <a:r>
-              <a:t>Community flywheel: every custom tool, skill, and agent benefits the ecosystem</a:t>
+              <a:defRPr sz="1300" b="0">
+                <a:solidFill>
+                  <a:srgbClr val="8B95A5"/>
+                </a:solidFill>
+                <a:latin typeface="Calibri"/>
+              </a:defRPr>
+            </a:pPr>
+            <a:r>
+              <a:t>Build 2-3 specialty agents (Lab, Pharmacy, Claims)</a:t>
             </a:r>
           </a:p>
           <a:p>
@@ -6860,7 +9014,146 @@
               <a:spcBef>
                 <a:spcPts val="400"/>
               </a:spcBef>
-              <a:defRPr sz="1500" b="0">
+              <a:defRPr sz="1300" b="0">
+                <a:solidFill>
+                  <a:srgbClr val="8B95A5"/>
+                </a:solidFill>
+                <a:latin typeface="Calibri"/>
+              </a:defRPr>
+            </a:pPr>
+            <a:r>
+              <a:t>Open tool/skill authoring to SE community</a:t>
+            </a:r>
+          </a:p>
+        </p:txBody>
+      </p:sp>
+      <p:sp>
+        <p:nvSpPr>
+          <p:cNvPr id="16" name="Rounded Rectangle 15"/>
+          <p:cNvSpPr/>
+          <p:nvPr/>
+        </p:nvSpPr>
+        <p:spPr>
+          <a:xfrm>
+            <a:off x="8138160" y="1645920"/>
+            <a:ext cx="3383280" cy="3474720"/>
+          </a:xfrm>
+          <a:prstGeom prst="roundRect">
+            <a:avLst/>
+          </a:prstGeom>
+          <a:solidFill>
+            <a:srgbClr val="13171E"/>
+          </a:solidFill>
+          <a:ln>
+            <a:noFill/>
+          </a:ln>
+        </p:spPr>
+        <p:style>
+          <a:lnRef idx="1">
+            <a:schemeClr val="accent1"/>
+          </a:lnRef>
+          <a:fillRef idx="3">
+            <a:schemeClr val="accent1"/>
+          </a:fillRef>
+          <a:effectRef idx="2">
+            <a:schemeClr val="accent1"/>
+          </a:effectRef>
+          <a:fontRef idx="minor">
+            <a:schemeClr val="lt1"/>
+          </a:fontRef>
+        </p:style>
+        <p:txBody>
+          <a:bodyPr rtlCol="0" anchor="ctr"/>
+          <a:lstStyle/>
+          <a:p>
+            <a:pPr algn="ctr"/>
+          </a:p>
+        </p:txBody>
+      </p:sp>
+      <p:sp>
+        <p:nvSpPr>
+          <p:cNvPr id="17" name="Rectangle 16"/>
+          <p:cNvSpPr/>
+          <p:nvPr/>
+        </p:nvSpPr>
+        <p:spPr>
+          <a:xfrm>
+            <a:off x="8138160" y="1645920"/>
+            <a:ext cx="3383280" cy="63500"/>
+          </a:xfrm>
+          <a:prstGeom prst="rect">
+            <a:avLst/>
+          </a:prstGeom>
+          <a:solidFill>
+            <a:srgbClr val="7C3AED"/>
+          </a:solidFill>
+          <a:ln>
+            <a:noFill/>
+          </a:ln>
+        </p:spPr>
+        <p:style>
+          <a:lnRef idx="1">
+            <a:schemeClr val="accent1"/>
+          </a:lnRef>
+          <a:fillRef idx="3">
+            <a:schemeClr val="accent1"/>
+          </a:fillRef>
+          <a:effectRef idx="2">
+            <a:schemeClr val="accent1"/>
+          </a:effectRef>
+          <a:fontRef idx="minor">
+            <a:schemeClr val="lt1"/>
+          </a:fontRef>
+        </p:style>
+        <p:txBody>
+          <a:bodyPr rtlCol="0" anchor="ctr"/>
+          <a:lstStyle/>
+          <a:p>
+            <a:pPr algn="ctr"/>
+          </a:p>
+        </p:txBody>
+      </p:sp>
+      <p:sp>
+        <p:nvSpPr>
+          <p:cNvPr id="18" name="Rounded Rectangle 17"/>
+          <p:cNvSpPr/>
+          <p:nvPr/>
+        </p:nvSpPr>
+        <p:spPr>
+          <a:xfrm>
+            <a:off x="8366760" y="1874520"/>
+            <a:ext cx="457200" cy="457200"/>
+          </a:xfrm>
+          <a:prstGeom prst="roundRect">
+            <a:avLst/>
+          </a:prstGeom>
+          <a:solidFill>
+            <a:srgbClr val="7C3AED"/>
+          </a:solidFill>
+          <a:ln>
+            <a:noFill/>
+          </a:ln>
+        </p:spPr>
+        <p:style>
+          <a:lnRef idx="1">
+            <a:schemeClr val="accent1"/>
+          </a:lnRef>
+          <a:fillRef idx="3">
+            <a:schemeClr val="accent1"/>
+          </a:fillRef>
+          <a:effectRef idx="2">
+            <a:schemeClr val="accent1"/>
+          </a:effectRef>
+          <a:fontRef idx="minor">
+            <a:schemeClr val="lt1"/>
+          </a:fontRef>
+        </p:style>
+        <p:txBody>
+          <a:bodyPr rtlCol="0" anchor="ctr" wrap="square" lIns="76200" rIns="76200" tIns="50800" bIns="50800"/>
+          <a:lstStyle/>
+          <a:p>
+            <a:pPr algn="ctr">
+              <a:defRPr sz="1600" b="1">
                 <a:solidFill>
                   <a:srgbClr val="E6E8EB"/>
                 </a:solidFill>
@@ -6868,21 +9161,21 @@
               </a:defRPr>
             </a:pPr>
             <a:r>
-              <a:t>Differentiator: no competitor offers an AI framework embedded in their integration engine</a:t>
-            </a:r>
-          </a:p>
-        </p:txBody>
-      </p:sp>
-      <p:sp>
-        <p:nvSpPr>
-          <p:cNvPr id="5" name="TextBox 4"/>
+              <a:t>3</a:t>
+            </a:r>
+          </a:p>
+        </p:txBody>
+      </p:sp>
+      <p:sp>
+        <p:nvSpPr>
+          <p:cNvPr id="19" name="TextBox 18"/>
           <p:cNvSpPr txBox="1"/>
           <p:nvPr/>
         </p:nvSpPr>
         <p:spPr>
           <a:xfrm>
-            <a:off x="6400800" y="1371600"/>
-            <a:ext cx="5029200" cy="4572000"/>
+            <a:off x="8961120" y="1874520"/>
+            <a:ext cx="2286000" cy="320040"/>
           </a:xfrm>
           <a:prstGeom prst="rect">
             <a:avLst/>
@@ -6896,31 +9189,100 @@
           <a:lstStyle/>
           <a:p>
             <a:pPr algn="l">
-              <a:defRPr sz="2000" b="1">
-                <a:solidFill>
-                  <a:srgbClr val="14B8A6"/>
-                </a:solidFill>
-                <a:latin typeface="Calibri"/>
-              </a:defRPr>
-            </a:pPr>
-            <a:r>
-              <a:t>Next Steps</a:t>
-            </a:r>
+              <a:defRPr sz="1400" b="1">
+                <a:solidFill>
+                  <a:srgbClr val="7C3AED"/>
+                </a:solidFill>
+                <a:latin typeface="Calibri"/>
+              </a:defRPr>
+            </a:pPr>
+            <a:r>
+              <a:t>2027</a:t>
+            </a:r>
+          </a:p>
+        </p:txBody>
+      </p:sp>
+      <p:sp>
+        <p:nvSpPr>
+          <p:cNvPr id="20" name="TextBox 19"/>
+          <p:cNvSpPr txBox="1"/>
+          <p:nvPr/>
+        </p:nvSpPr>
+        <p:spPr>
+          <a:xfrm>
+            <a:off x="8961120" y="2148840"/>
+            <a:ext cx="2286000" cy="274320"/>
+          </a:xfrm>
+          <a:prstGeom prst="rect">
+            <a:avLst/>
+          </a:prstGeom>
+          <a:noFill/>
+        </p:spPr>
+        <p:txBody>
+          <a:bodyPr wrap="square">
+            <a:spAutoFit/>
+          </a:bodyPr>
+          <a:lstStyle/>
+          <a:p>
+            <a:pPr algn="l">
+              <a:defRPr sz="1800" b="1">
+                <a:solidFill>
+                  <a:srgbClr val="E6E8EB"/>
+                </a:solidFill>
+                <a:latin typeface="Calibri"/>
+              </a:defRPr>
+            </a:pPr>
+            <a:r>
+              <a:t>Ecosystem</a:t>
+            </a:r>
+          </a:p>
+        </p:txBody>
+      </p:sp>
+      <p:sp>
+        <p:nvSpPr>
+          <p:cNvPr id="21" name="TextBox 20"/>
+          <p:cNvSpPr txBox="1"/>
+          <p:nvPr/>
+        </p:nvSpPr>
+        <p:spPr>
+          <a:xfrm>
+            <a:off x="8366760" y="2651760"/>
+            <a:ext cx="2926080" cy="2286000"/>
+          </a:xfrm>
+          <a:prstGeom prst="rect">
+            <a:avLst/>
+          </a:prstGeom>
+          <a:noFill/>
+        </p:spPr>
+        <p:txBody>
+          <a:bodyPr wrap="square">
+            <a:spAutoFit/>
+          </a:bodyPr>
+          <a:lstStyle/>
+          <a:p>
+            <a:pPr algn="l">
+              <a:defRPr sz="1300" b="0">
+                <a:solidFill>
+                  <a:srgbClr val="E6E8EB"/>
+                </a:solidFill>
+                <a:latin typeface="Calibri"/>
+              </a:defRPr>
+            </a:pPr>
           </a:p>
           <a:p>
             <a:pPr>
               <a:spcBef>
                 <a:spcPts val="400"/>
               </a:spcBef>
-              <a:defRPr sz="1500" b="0">
-                <a:solidFill>
-                  <a:srgbClr val="E6E8EB"/>
-                </a:solidFill>
-                <a:latin typeface="Calibri"/>
-              </a:defRPr>
-            </a:pPr>
-            <a:r>
-              <a:t>Fix the two blocker bugs (Skill $ZF marshaling, Bedrock tool-result hang)</a:t>
+              <a:defRPr sz="1300" b="0">
+                <a:solidFill>
+                  <a:srgbClr val="8B95A5"/>
+                </a:solidFill>
+                <a:latin typeface="Calibri"/>
+              </a:defRPr>
+            </a:pPr>
+            <a:r>
+              <a:t>Publish to Open Exchange</a:t>
             </a:r>
           </a:p>
           <a:p>
@@ -6928,15 +9290,15 @@
               <a:spcBef>
                 <a:spcPts val="400"/>
               </a:spcBef>
-              <a:defRPr sz="1500" b="0">
-                <a:solidFill>
-                  <a:srgbClr val="E6E8EB"/>
-                </a:solidFill>
-                <a:latin typeface="Calibri"/>
-              </a:defRPr>
-            </a:pPr>
-            <a:r>
-              <a:t>Ship ToolFilter policy as a framework default</a:t>
+              <a:defRPr sz="1300" b="0">
+                <a:solidFill>
+                  <a:srgbClr val="8B95A5"/>
+                </a:solidFill>
+                <a:latin typeface="Calibri"/>
+              </a:defRPr>
+            </a:pPr>
+            <a:r>
+              <a:t>SE accelerator library (20+ patterns)</a:t>
             </a:r>
           </a:p>
           <a:p>
@@ -6944,63 +9306,51 @@
               <a:spcBef>
                 <a:spcPts val="400"/>
               </a:spcBef>
-              <a:defRPr sz="1500" b="0">
-                <a:solidFill>
-                  <a:srgbClr val="E6E8EB"/>
-                </a:solidFill>
-                <a:latin typeface="Calibri"/>
-              </a:defRPr>
-            </a:pPr>
-            <a:r>
-              <a:t>Package as IPM module for field trial with 3 customers</a:t>
-            </a:r>
-          </a:p>
-          <a:p>
-            <a:pPr>
-              <a:spcBef>
-                <a:spcPts val="400"/>
-              </a:spcBef>
-              <a:defRPr sz="1500" b="0">
-                <a:solidFill>
-                  <a:srgbClr val="E6E8EB"/>
-                </a:solidFill>
-                <a:latin typeface="Calibri"/>
-              </a:defRPr>
-            </a:pPr>
-            <a:r>
-              <a:t>Build 2-3 additional use-case agents (Lab, Pharmacy, Claims)</a:t>
-            </a:r>
-          </a:p>
-          <a:p>
-            <a:pPr>
-              <a:spcBef>
-                <a:spcPts val="400"/>
-              </a:spcBef>
-              <a:defRPr sz="1500" b="0">
-                <a:solidFill>
-                  <a:srgbClr val="E6E8EB"/>
-                </a:solidFill>
-                <a:latin typeface="Calibri"/>
-              </a:defRPr>
-            </a:pPr>
-            <a:r>
-              <a:t>Open the tool/skill authoring to the SE community</a:t>
-            </a:r>
-          </a:p>
-          <a:p>
-            <a:pPr>
-              <a:spcBef>
-                <a:spcPts val="400"/>
-              </a:spcBef>
-              <a:defRPr sz="1500" b="0">
-                <a:solidFill>
-                  <a:srgbClr val="E6E8EB"/>
-                </a:solidFill>
-                <a:latin typeface="Calibri"/>
-              </a:defRPr>
-            </a:pPr>
-            <a:r>
-              <a:t>Publish to Open Exchange for community contributions</a:t>
+              <a:defRPr sz="1300" b="0">
+                <a:solidFill>
+                  <a:srgbClr val="8B95A5"/>
+                </a:solidFill>
+                <a:latin typeface="Calibri"/>
+              </a:defRPr>
+            </a:pPr>
+            <a:r>
+              <a:t>Community marketplace for tools and skills</a:t>
+            </a:r>
+          </a:p>
+        </p:txBody>
+      </p:sp>
+      <p:sp>
+        <p:nvSpPr>
+          <p:cNvPr id="22" name="TextBox 21"/>
+          <p:cNvSpPr txBox="1"/>
+          <p:nvPr/>
+        </p:nvSpPr>
+        <p:spPr>
+          <a:xfrm>
+            <a:off x="731520" y="5669280"/>
+            <a:ext cx="10515600" cy="457200"/>
+          </a:xfrm>
+          <a:prstGeom prst="rect">
+            <a:avLst/>
+          </a:prstGeom>
+          <a:noFill/>
+        </p:spPr>
+        <p:txBody>
+          <a:bodyPr wrap="square">
+            <a:spAutoFit/>
+          </a:bodyPr>
+          <a:lstStyle/>
+          <a:p>
+            <a:pPr algn="ctr">
+              <a:defRPr sz="1100" b="0">
+                <a:solidFill>
+                  <a:srgbClr val="8B95A5"/>
+                </a:solidFill>
+                <a:latin typeface="Calibri"/>
+              </a:defRPr>
+            </a:pPr>
+            <a:r>
+              <a:t>Built on IRIS for Health 2026.2  |  %AI Framework build 162.0  |  61 classes, 42 tools, 12 skills  |  Ready for field trial</a:t>
             </a:r>
           </a:p>
         </p:txBody>

</xml_diff>